<commit_message>
feat: format coverage, tabular chunker, file exclusion & unassigned view — v0.6.1-alpha
- formats: .odg support (LibreOffice -> PDF); SUPPORTED_FORMATS.md generated from the authoritative whitelist (48 ext); fixtures now cover .docx/.doc/.rtf/.odg (gen_fixtures no longer emits empty Word files silently).
- tabular: dedicated CSV/XLSX chunker (table card + verbalized rows up to a cap) so large tables no longer return zero chunks from Docling; handles the IT dialect (';' separator, comma decimals); tunable via SOPHIA_VECTOR_TABULAR_*.
- exclusions: mark a file EXCLUDED -> vector worker, SharePoint sync and every source skip it (even on cron) and already-indexed data is purged; reversible; API + UI; single source of truth (utils/exclusions.py).
- ui: fixed 'Senza directory' card lists/manages files ingested via the API without a directory slug.
- build: Dockerfile.cu130 COPY models/ + CUDA-by-default; compile-and-publish builds cpu+cu130 with position-independent args.
</commit_message>
<xml_diff>
--- a/tests/fixtures/sample.pptx
+++ b/tests/fixtures/sample.pptx
@@ -143,7 +143,7 @@
         <p:txBody>
           <a:bodyPr/>
           <a:p>
-            <a:fld id="{0AB9BCCE-188A-40E2-928A-6E3DF450C199}" type="slidenum">
+            <a:fld id="{84F2218C-C939-4D83-B4AB-BF88C1D09724}" type="slidenum">
               <a:t>&lt;#&gt;</a:t>
             </a:fld>
           </a:p>
@@ -628,7 +628,7 @@
             <a:pPr indent="0" algn="r">
               <a:buNone/>
             </a:pPr>
-            <a:fld id="{4453BF4F-2E18-410C-B07B-8D601BE41A39}" type="slidenum">
+            <a:fld id="{AE8C15A7-F837-427A-A2F9-209B447ED717}" type="slidenum">
               <a:rPr b="0" lang="it-IT" sz="1400" spc="-1" strike="noStrike">
                 <a:solidFill>
                   <a:srgbClr val="000000"/>

</xml_diff>